<commit_message>
adding missing data info
</commit_message>
<xml_diff>
--- a/docs/lessons/17_Missing_data/17_Activity_dogs.pptx
+++ b/docs/lessons/17_Missing_data/17_Activity_dogs.pptx
@@ -5,17 +5,16 @@
     <p:sldMasterId id="2147483701" r:id="rId1"/>
   </p:sldMasterIdLst>
   <p:notesMasterIdLst>
-    <p:notesMasterId r:id="rId10"/>
+    <p:notesMasterId r:id="rId9"/>
   </p:notesMasterIdLst>
   <p:sldIdLst>
     <p:sldId id="263" r:id="rId2"/>
-    <p:sldId id="261" r:id="rId3"/>
-    <p:sldId id="265" r:id="rId4"/>
-    <p:sldId id="267" r:id="rId5"/>
-    <p:sldId id="257" r:id="rId6"/>
-    <p:sldId id="260" r:id="rId7"/>
-    <p:sldId id="264" r:id="rId8"/>
-    <p:sldId id="262" r:id="rId9"/>
+    <p:sldId id="265" r:id="rId3"/>
+    <p:sldId id="267" r:id="rId4"/>
+    <p:sldId id="257" r:id="rId5"/>
+    <p:sldId id="260" r:id="rId6"/>
+    <p:sldId id="264" r:id="rId7"/>
+    <p:sldId id="262" r:id="rId8"/>
   </p:sldIdLst>
   <p:sldSz cx="12192000" cy="6858000"/>
   <p:notesSz cx="6858000" cy="9144000"/>
@@ -125,7 +124,7 @@
 <file path=ppt/revisionInfo.xml><?xml version="1.0" encoding="utf-8"?>
 <p1510:revInfo xmlns:a="http://schemas.openxmlformats.org/drawingml/2006/main" xmlns:r="http://schemas.openxmlformats.org/officeDocument/2006/relationships" xmlns:p1510="http://schemas.microsoft.com/office/powerpoint/2015/10/main">
   <p1510:revLst>
-    <p1510:client id="{8D2B82ED-A89B-CD49-8464-8777A0F671B9}" v="6" dt="2026-06-03T00:09:16.998"/>
+    <p1510:client id="{8D2B82ED-A89B-CD49-8464-8777A0F671B9}" v="13" dt="2026-06-03T21:14:37.967"/>
   </p1510:revLst>
 </p1510:revInfo>
 </file>
@@ -135,7 +134,7 @@
   <pc:docChgLst>
     <pc:chgData name="Nicky Wakim" userId="63a62853-8dd4-431b-8872-ecc2181a70d8" providerId="ADAL" clId="{88AEBF9D-5A98-5D2C-A60C-905B4F0F6AB9}"/>
     <pc:docChg chg="custSel addSld delSld modSld sldOrd">
-      <pc:chgData name="Nicky Wakim" userId="63a62853-8dd4-431b-8872-ecc2181a70d8" providerId="ADAL" clId="{88AEBF9D-5A98-5D2C-A60C-905B4F0F6AB9}" dt="2026-06-03T00:10:06.338" v="783" actId="20577"/>
+      <pc:chgData name="Nicky Wakim" userId="63a62853-8dd4-431b-8872-ecc2181a70d8" providerId="ADAL" clId="{88AEBF9D-5A98-5D2C-A60C-905B4F0F6AB9}" dt="2026-06-03T21:17:35.359" v="1022" actId="1076"/>
       <pc:docMkLst>
         <pc:docMk/>
       </pc:docMkLst>
@@ -209,6 +208,13 @@
           <pc:sldMk cId="3978935957" sldId="259"/>
         </pc:sldMkLst>
       </pc:sldChg>
+      <pc:sldChg chg="del">
+        <pc:chgData name="Nicky Wakim" userId="63a62853-8dd4-431b-8872-ecc2181a70d8" providerId="ADAL" clId="{88AEBF9D-5A98-5D2C-A60C-905B4F0F6AB9}" dt="2026-06-03T21:05:38.368" v="784" actId="2696"/>
+        <pc:sldMkLst>
+          <pc:docMk/>
+          <pc:sldMk cId="2537736449" sldId="261"/>
+        </pc:sldMkLst>
+      </pc:sldChg>
       <pc:sldChg chg="modSp mod">
         <pc:chgData name="Nicky Wakim" userId="63a62853-8dd4-431b-8872-ecc2181a70d8" providerId="ADAL" clId="{88AEBF9D-5A98-5D2C-A60C-905B4F0F6AB9}" dt="2026-06-03T00:10:06.338" v="783" actId="20577"/>
         <pc:sldMkLst>
@@ -225,13 +231,13 @@
         </pc:spChg>
       </pc:sldChg>
       <pc:sldChg chg="modSp add mod">
-        <pc:chgData name="Nicky Wakim" userId="63a62853-8dd4-431b-8872-ecc2181a70d8" providerId="ADAL" clId="{88AEBF9D-5A98-5D2C-A60C-905B4F0F6AB9}" dt="2026-06-03T00:05:04.202" v="723" actId="20577"/>
+        <pc:chgData name="Nicky Wakim" userId="63a62853-8dd4-431b-8872-ecc2181a70d8" providerId="ADAL" clId="{88AEBF9D-5A98-5D2C-A60C-905B4F0F6AB9}" dt="2026-06-03T21:14:10.979" v="991" actId="20577"/>
         <pc:sldMkLst>
           <pc:docMk/>
           <pc:sldMk cId="2706038391" sldId="265"/>
         </pc:sldMkLst>
         <pc:spChg chg="mod">
-          <ac:chgData name="Nicky Wakim" userId="63a62853-8dd4-431b-8872-ecc2181a70d8" providerId="ADAL" clId="{88AEBF9D-5A98-5D2C-A60C-905B4F0F6AB9}" dt="2026-06-03T00:05:04.202" v="723" actId="20577"/>
+          <ac:chgData name="Nicky Wakim" userId="63a62853-8dd4-431b-8872-ecc2181a70d8" providerId="ADAL" clId="{88AEBF9D-5A98-5D2C-A60C-905B4F0F6AB9}" dt="2026-06-03T21:14:10.979" v="991" actId="20577"/>
           <ac:spMkLst>
             <pc:docMk/>
             <pc:sldMk cId="2706038391" sldId="265"/>
@@ -246,42 +252,98 @@
           <pc:sldMk cId="3737910894" sldId="266"/>
         </pc:sldMkLst>
       </pc:sldChg>
-      <pc:sldChg chg="addSp modSp new mod">
-        <pc:chgData name="Nicky Wakim" userId="63a62853-8dd4-431b-8872-ecc2181a70d8" providerId="ADAL" clId="{88AEBF9D-5A98-5D2C-A60C-905B4F0F6AB9}" dt="2026-06-03T00:09:36.853" v="777" actId="255"/>
+      <pc:sldChg chg="addSp delSp modSp new mod">
+        <pc:chgData name="Nicky Wakim" userId="63a62853-8dd4-431b-8872-ecc2181a70d8" providerId="ADAL" clId="{88AEBF9D-5A98-5D2C-A60C-905B4F0F6AB9}" dt="2026-06-03T21:17:35.359" v="1022" actId="1076"/>
         <pc:sldMkLst>
           <pc:docMk/>
           <pc:sldMk cId="2625414403" sldId="267"/>
         </pc:sldMkLst>
-        <pc:spChg chg="add mod">
-          <ac:chgData name="Nicky Wakim" userId="63a62853-8dd4-431b-8872-ecc2181a70d8" providerId="ADAL" clId="{88AEBF9D-5A98-5D2C-A60C-905B4F0F6AB9}" dt="2026-06-03T00:06:36.891" v="743" actId="14100"/>
+        <pc:spChg chg="add del mod">
+          <ac:chgData name="Nicky Wakim" userId="63a62853-8dd4-431b-8872-ecc2181a70d8" providerId="ADAL" clId="{88AEBF9D-5A98-5D2C-A60C-905B4F0F6AB9}" dt="2026-06-03T21:14:31.348" v="994" actId="478"/>
           <ac:spMkLst>
             <pc:docMk/>
             <pc:sldMk cId="2625414403" sldId="267"/>
             <ac:spMk id="3" creationId="{80640622-CD0A-12E1-2990-43DA118784DC}"/>
           </ac:spMkLst>
         </pc:spChg>
-        <pc:spChg chg="add mod">
-          <ac:chgData name="Nicky Wakim" userId="63a62853-8dd4-431b-8872-ecc2181a70d8" providerId="ADAL" clId="{88AEBF9D-5A98-5D2C-A60C-905B4F0F6AB9}" dt="2026-06-03T00:06:36.891" v="743" actId="14100"/>
+        <pc:spChg chg="add del mod">
+          <ac:chgData name="Nicky Wakim" userId="63a62853-8dd4-431b-8872-ecc2181a70d8" providerId="ADAL" clId="{88AEBF9D-5A98-5D2C-A60C-905B4F0F6AB9}" dt="2026-06-03T21:15:24.216" v="1013" actId="478"/>
           <ac:spMkLst>
             <pc:docMk/>
             <pc:sldMk cId="2625414403" sldId="267"/>
             <ac:spMk id="4" creationId="{B2EFA23B-ECB3-AA31-C83D-2369F74E6BDA}"/>
           </ac:spMkLst>
         </pc:spChg>
-        <pc:spChg chg="add mod">
-          <ac:chgData name="Nicky Wakim" userId="63a62853-8dd4-431b-8872-ecc2181a70d8" providerId="ADAL" clId="{88AEBF9D-5A98-5D2C-A60C-905B4F0F6AB9}" dt="2026-06-03T00:06:36.891" v="743" actId="14100"/>
+        <pc:spChg chg="add del mod">
+          <ac:chgData name="Nicky Wakim" userId="63a62853-8dd4-431b-8872-ecc2181a70d8" providerId="ADAL" clId="{88AEBF9D-5A98-5D2C-A60C-905B4F0F6AB9}" dt="2026-06-03T21:14:32.490" v="995" actId="478"/>
           <ac:spMkLst>
             <pc:docMk/>
             <pc:sldMk cId="2625414403" sldId="267"/>
             <ac:spMk id="5" creationId="{92C4BBCC-9CFE-34D2-C59C-0DFF773474F9}"/>
           </ac:spMkLst>
         </pc:spChg>
-        <pc:spChg chg="add mod">
-          <ac:chgData name="Nicky Wakim" userId="63a62853-8dd4-431b-8872-ecc2181a70d8" providerId="ADAL" clId="{88AEBF9D-5A98-5D2C-A60C-905B4F0F6AB9}" dt="2026-06-03T00:06:36.891" v="743" actId="14100"/>
+        <pc:spChg chg="add del mod">
+          <ac:chgData name="Nicky Wakim" userId="63a62853-8dd4-431b-8872-ecc2181a70d8" providerId="ADAL" clId="{88AEBF9D-5A98-5D2C-A60C-905B4F0F6AB9}" dt="2026-06-03T21:14:33.557" v="996" actId="478"/>
           <ac:spMkLst>
             <pc:docMk/>
             <pc:sldMk cId="2625414403" sldId="267"/>
             <ac:spMk id="6" creationId="{37C5154C-91EF-E26E-E0CE-CE84D97B18DB}"/>
+          </ac:spMkLst>
+        </pc:spChg>
+        <pc:spChg chg="add del mod">
+          <ac:chgData name="Nicky Wakim" userId="63a62853-8dd4-431b-8872-ecc2181a70d8" providerId="ADAL" clId="{88AEBF9D-5A98-5D2C-A60C-905B4F0F6AB9}" dt="2026-06-03T21:15:23.135" v="1012" actId="478"/>
+          <ac:spMkLst>
+            <pc:docMk/>
+            <pc:sldMk cId="2625414403" sldId="267"/>
+            <ac:spMk id="7" creationId="{C6C53190-B4DC-F04A-D986-6390114E532C}"/>
+          </ac:spMkLst>
+        </pc:spChg>
+        <pc:spChg chg="add del mod">
+          <ac:chgData name="Nicky Wakim" userId="63a62853-8dd4-431b-8872-ecc2181a70d8" providerId="ADAL" clId="{88AEBF9D-5A98-5D2C-A60C-905B4F0F6AB9}" dt="2026-06-03T21:15:21.610" v="1011" actId="478"/>
+          <ac:spMkLst>
+            <pc:docMk/>
+            <pc:sldMk cId="2625414403" sldId="267"/>
+            <ac:spMk id="8" creationId="{F6C0ADBF-9EC9-378C-5C7A-CCC28BD7C592}"/>
+          </ac:spMkLst>
+        </pc:spChg>
+        <pc:spChg chg="add mod">
+          <ac:chgData name="Nicky Wakim" userId="63a62853-8dd4-431b-8872-ecc2181a70d8" providerId="ADAL" clId="{88AEBF9D-5A98-5D2C-A60C-905B4F0F6AB9}" dt="2026-06-03T21:16:44.525" v="1018" actId="14100"/>
+          <ac:spMkLst>
+            <pc:docMk/>
+            <pc:sldMk cId="2625414403" sldId="267"/>
+            <ac:spMk id="9" creationId="{21C2D89B-9296-E8FB-C3A6-4E9AD2D446DE}"/>
+          </ac:spMkLst>
+        </pc:spChg>
+        <pc:spChg chg="add mod">
+          <ac:chgData name="Nicky Wakim" userId="63a62853-8dd4-431b-8872-ecc2181a70d8" providerId="ADAL" clId="{88AEBF9D-5A98-5D2C-A60C-905B4F0F6AB9}" dt="2026-06-03T21:16:51.008" v="1021" actId="14100"/>
+          <ac:spMkLst>
+            <pc:docMk/>
+            <pc:sldMk cId="2625414403" sldId="267"/>
+            <ac:spMk id="10" creationId="{B954FECB-A05C-7063-0F69-60A9352C51EF}"/>
+          </ac:spMkLst>
+        </pc:spChg>
+        <pc:spChg chg="add mod">
+          <ac:chgData name="Nicky Wakim" userId="63a62853-8dd4-431b-8872-ecc2181a70d8" providerId="ADAL" clId="{88AEBF9D-5A98-5D2C-A60C-905B4F0F6AB9}" dt="2026-06-03T21:17:35.359" v="1022" actId="1076"/>
+          <ac:spMkLst>
+            <pc:docMk/>
+            <pc:sldMk cId="2625414403" sldId="267"/>
+            <ac:spMk id="11" creationId="{8E2F7161-B525-D777-225F-D6DFF6E74DF8}"/>
+          </ac:spMkLst>
+        </pc:spChg>
+        <pc:spChg chg="add mod">
+          <ac:chgData name="Nicky Wakim" userId="63a62853-8dd4-431b-8872-ecc2181a70d8" providerId="ADAL" clId="{88AEBF9D-5A98-5D2C-A60C-905B4F0F6AB9}" dt="2026-06-03T21:16:46.942" v="1019" actId="14100"/>
+          <ac:spMkLst>
+            <pc:docMk/>
+            <pc:sldMk cId="2625414403" sldId="267"/>
+            <ac:spMk id="12" creationId="{F05A0DDA-5AD8-2A70-1A1B-73CAF24C46FF}"/>
+          </ac:spMkLst>
+        </pc:spChg>
+        <pc:spChg chg="add del mod">
+          <ac:chgData name="Nicky Wakim" userId="63a62853-8dd4-431b-8872-ecc2181a70d8" providerId="ADAL" clId="{88AEBF9D-5A98-5D2C-A60C-905B4F0F6AB9}" dt="2026-06-03T21:15:08.536" v="1007" actId="478"/>
+          <ac:spMkLst>
+            <pc:docMk/>
+            <pc:sldMk cId="2625414403" sldId="267"/>
+            <ac:spMk id="13" creationId="{787C3586-6243-0905-6ECA-613D483F106F}"/>
           </ac:spMkLst>
         </pc:spChg>
         <pc:graphicFrameChg chg="add mod modGraphic">
@@ -380,7 +442,7 @@
           <a:p>
             <a:fld id="{114978BC-B06D-E54B-9425-EAE9C145D3AE}" type="datetimeFigureOut">
               <a:rPr lang="en-US" smtClean="0"/>
-              <a:t>6/2/26</a:t>
+              <a:t>6/3/26</a:t>
             </a:fld>
             <a:endParaRPr lang="en-US"/>
           </a:p>
@@ -712,91 +774,7 @@
           <a:p>
             <a:fld id="{ED1D2874-A4D8-8A4B-8E79-7C028EBF4A52}" type="slidenum">
               <a:rPr lang="en-US" smtClean="0"/>
-              <a:t>2</a:t>
-            </a:fld>
-            <a:endParaRPr lang="en-US"/>
-          </a:p>
-        </p:txBody>
-      </p:sp>
-    </p:spTree>
-    <p:extLst>
-      <p:ext uri="{BB962C8B-B14F-4D97-AF65-F5344CB8AC3E}">
-        <p14:creationId xmlns:p14="http://schemas.microsoft.com/office/powerpoint/2010/main" val="2805083339"/>
-      </p:ext>
-    </p:extLst>
-  </p:cSld>
-  <p:clrMapOvr>
-    <a:masterClrMapping/>
-  </p:clrMapOvr>
-</p:notes>
-</file>
-
-<file path=ppt/notesSlides/notesSlide2.xml><?xml version="1.0" encoding="utf-8"?>
-<p:notes xmlns:a="http://schemas.openxmlformats.org/drawingml/2006/main" xmlns:r="http://schemas.openxmlformats.org/officeDocument/2006/relationships" xmlns:p="http://schemas.openxmlformats.org/presentationml/2006/main">
-  <p:cSld>
-    <p:spTree>
-      <p:nvGrpSpPr>
-        <p:cNvPr id="1" name=""/>
-        <p:cNvGrpSpPr/>
-        <p:nvPr/>
-      </p:nvGrpSpPr>
-      <p:grpSpPr>
-        <a:xfrm>
-          <a:off x="0" y="0"/>
-          <a:ext cx="0" cy="0"/>
-          <a:chOff x="0" y="0"/>
-          <a:chExt cx="0" cy="0"/>
-        </a:xfrm>
-      </p:grpSpPr>
-      <p:sp>
-        <p:nvSpPr>
-          <p:cNvPr id="2" name="Slide Image Placeholder 1"/>
-          <p:cNvSpPr>
-            <a:spLocks noGrp="1" noRot="1" noChangeAspect="1"/>
-          </p:cNvSpPr>
-          <p:nvPr>
-            <p:ph type="sldImg"/>
-          </p:nvPr>
-        </p:nvSpPr>
-        <p:spPr/>
-      </p:sp>
-      <p:sp>
-        <p:nvSpPr>
-          <p:cNvPr id="3" name="Notes Placeholder 2"/>
-          <p:cNvSpPr>
-            <a:spLocks noGrp="1"/>
-          </p:cNvSpPr>
-          <p:nvPr>
-            <p:ph type="body" idx="1"/>
-          </p:nvPr>
-        </p:nvSpPr>
-        <p:spPr/>
-        <p:txBody>
-          <a:bodyPr/>
-          <a:lstStyle/>
-          <a:p>
-            <a:endParaRPr lang="en-US" dirty="0"/>
-          </a:p>
-        </p:txBody>
-      </p:sp>
-      <p:sp>
-        <p:nvSpPr>
-          <p:cNvPr id="4" name="Slide Number Placeholder 3"/>
-          <p:cNvSpPr>
-            <a:spLocks noGrp="1"/>
-          </p:cNvSpPr>
-          <p:nvPr>
-            <p:ph type="sldNum" sz="quarter" idx="5"/>
-          </p:nvPr>
-        </p:nvSpPr>
-        <p:spPr/>
-        <p:txBody>
-          <a:bodyPr/>
-          <a:lstStyle/>
-          <a:p>
-            <a:fld id="{ED1D2874-A4D8-8A4B-8E79-7C028EBF4A52}" type="slidenum">
-              <a:rPr lang="en-US" smtClean="0"/>
-              <a:t>5</a:t>
+              <a:t>4</a:t>
             </a:fld>
             <a:endParaRPr lang="en-US"/>
           </a:p>
@@ -970,7 +948,7 @@
           <a:p>
             <a:fld id="{BCC16B26-9395-B44B-9BD0-B3EFFDF164FD}" type="datetimeFigureOut">
               <a:rPr lang="en-US" smtClean="0"/>
-              <a:t>6/2/26</a:t>
+              <a:t>6/3/26</a:t>
             </a:fld>
             <a:endParaRPr lang="en-US"/>
           </a:p>
@@ -1245,7 +1223,7 @@
           <a:p>
             <a:fld id="{BCC16B26-9395-B44B-9BD0-B3EFFDF164FD}" type="datetimeFigureOut">
               <a:rPr lang="en-US" smtClean="0"/>
-              <a:t>6/2/26</a:t>
+              <a:t>6/3/26</a:t>
             </a:fld>
             <a:endParaRPr lang="en-US"/>
           </a:p>
@@ -1415,7 +1393,7 @@
           <a:p>
             <a:fld id="{BCC16B26-9395-B44B-9BD0-B3EFFDF164FD}" type="datetimeFigureOut">
               <a:rPr lang="en-US" smtClean="0"/>
-              <a:t>6/2/26</a:t>
+              <a:t>6/3/26</a:t>
             </a:fld>
             <a:endParaRPr lang="en-US"/>
           </a:p>
@@ -1595,7 +1573,7 @@
           <a:p>
             <a:fld id="{BCC16B26-9395-B44B-9BD0-B3EFFDF164FD}" type="datetimeFigureOut">
               <a:rPr lang="en-US" smtClean="0"/>
-              <a:t>6/2/26</a:t>
+              <a:t>6/3/26</a:t>
             </a:fld>
             <a:endParaRPr lang="en-US"/>
           </a:p>
@@ -1765,7 +1743,7 @@
           <a:p>
             <a:fld id="{BCC16B26-9395-B44B-9BD0-B3EFFDF164FD}" type="datetimeFigureOut">
               <a:rPr lang="en-US" smtClean="0"/>
-              <a:t>6/2/26</a:t>
+              <a:t>6/3/26</a:t>
             </a:fld>
             <a:endParaRPr lang="en-US"/>
           </a:p>
@@ -1888,7 +1866,7 @@
           <a:p>
             <a:fld id="{BCC16B26-9395-B44B-9BD0-B3EFFDF164FD}" type="datetimeFigureOut">
               <a:rPr lang="en-US" smtClean="0"/>
-              <a:t>6/2/26</a:t>
+              <a:t>6/3/26</a:t>
             </a:fld>
             <a:endParaRPr lang="en-US"/>
           </a:p>
@@ -2102,7 +2080,7 @@
           <a:p>
             <a:fld id="{BCC16B26-9395-B44B-9BD0-B3EFFDF164FD}" type="datetimeFigureOut">
               <a:rPr lang="en-US" smtClean="0"/>
-              <a:t>6/2/26</a:t>
+              <a:t>6/3/26</a:t>
             </a:fld>
             <a:endParaRPr lang="en-US"/>
           </a:p>
@@ -2316,7 +2294,7 @@
           <a:p>
             <a:fld id="{BCC16B26-9395-B44B-9BD0-B3EFFDF164FD}" type="datetimeFigureOut">
               <a:rPr lang="en-US" smtClean="0"/>
-              <a:t>6/2/26</a:t>
+              <a:t>6/3/26</a:t>
             </a:fld>
             <a:endParaRPr lang="en-US"/>
           </a:p>
@@ -2547,7 +2525,7 @@
           <a:p>
             <a:fld id="{BCC16B26-9395-B44B-9BD0-B3EFFDF164FD}" type="datetimeFigureOut">
               <a:rPr lang="en-US" smtClean="0"/>
-              <a:t>6/2/26</a:t>
+              <a:t>6/3/26</a:t>
             </a:fld>
             <a:endParaRPr lang="en-US"/>
           </a:p>
@@ -2898,7 +2876,7 @@
           <a:p>
             <a:fld id="{BCC16B26-9395-B44B-9BD0-B3EFFDF164FD}" type="datetimeFigureOut">
               <a:rPr lang="en-US" smtClean="0"/>
-              <a:t>6/2/26</a:t>
+              <a:t>6/3/26</a:t>
             </a:fld>
             <a:endParaRPr lang="en-US"/>
           </a:p>
@@ -3130,7 +3108,7 @@
           <a:p>
             <a:fld id="{BCC16B26-9395-B44B-9BD0-B3EFFDF164FD}" type="datetimeFigureOut">
               <a:rPr lang="en-US" smtClean="0"/>
-              <a:t>6/2/26</a:t>
+              <a:t>6/3/26</a:t>
             </a:fld>
             <a:endParaRPr lang="en-US"/>
           </a:p>
@@ -3497,7 +3475,7 @@
           <a:p>
             <a:fld id="{BCC16B26-9395-B44B-9BD0-B3EFFDF164FD}" type="datetimeFigureOut">
               <a:rPr lang="en-US" smtClean="0"/>
-              <a:t>6/2/26</a:t>
+              <a:t>6/3/26</a:t>
             </a:fld>
             <a:endParaRPr lang="en-US"/>
           </a:p>
@@ -3615,7 +3593,7 @@
           <a:p>
             <a:fld id="{BCC16B26-9395-B44B-9BD0-B3EFFDF164FD}" type="datetimeFigureOut">
               <a:rPr lang="en-US" smtClean="0"/>
-              <a:t>6/2/26</a:t>
+              <a:t>6/3/26</a:t>
             </a:fld>
             <a:endParaRPr lang="en-US"/>
           </a:p>
@@ -3710,7 +3688,7 @@
           <a:p>
             <a:fld id="{BCC16B26-9395-B44B-9BD0-B3EFFDF164FD}" type="datetimeFigureOut">
               <a:rPr lang="en-US" smtClean="0"/>
-              <a:t>6/2/26</a:t>
+              <a:t>6/3/26</a:t>
             </a:fld>
             <a:endParaRPr lang="en-US"/>
           </a:p>
@@ -3987,7 +3965,7 @@
           <a:p>
             <a:fld id="{BCC16B26-9395-B44B-9BD0-B3EFFDF164FD}" type="datetimeFigureOut">
               <a:rPr lang="en-US" smtClean="0"/>
-              <a:t>6/2/26</a:t>
+              <a:t>6/3/26</a:t>
             </a:fld>
             <a:endParaRPr lang="en-US"/>
           </a:p>
@@ -4200,7 +4178,7 @@
           <a:p>
             <a:fld id="{BCC16B26-9395-B44B-9BD0-B3EFFDF164FD}" type="datetimeFigureOut">
               <a:rPr lang="en-US" smtClean="0"/>
-              <a:t>6/2/26</a:t>
+              <a:t>6/3/26</a:t>
             </a:fld>
             <a:endParaRPr lang="en-US"/>
           </a:p>
@@ -4680,123 +4658,6 @@
   <p:cSld>
     <p:spTree>
       <p:nvGrpSpPr>
-        <p:cNvPr id="1" name=""/>
-        <p:cNvGrpSpPr/>
-        <p:nvPr/>
-      </p:nvGrpSpPr>
-      <p:grpSpPr>
-        <a:xfrm>
-          <a:off x="0" y="0"/>
-          <a:ext cx="0" cy="0"/>
-          <a:chOff x="0" y="0"/>
-          <a:chExt cx="0" cy="0"/>
-        </a:xfrm>
-      </p:grpSpPr>
-      <p:pic>
-        <p:nvPicPr>
-          <p:cNvPr id="3" name="Picture 2">
-            <a:extLst>
-              <a:ext uri="{FF2B5EF4-FFF2-40B4-BE49-F238E27FC236}">
-                <a16:creationId xmlns:a16="http://schemas.microsoft.com/office/drawing/2014/main" id="{AFB0EE8D-3561-2543-7B71-9E30F8684DC5}"/>
-              </a:ext>
-            </a:extLst>
-          </p:cNvPr>
-          <p:cNvPicPr>
-            <a:picLocks noChangeAspect="1"/>
-          </p:cNvPicPr>
-          <p:nvPr/>
-        </p:nvPicPr>
-        <p:blipFill rotWithShape="1">
-          <a:blip r:embed="rId3"/>
-          <a:srcRect t="3809" b="25506"/>
-          <a:stretch/>
-        </p:blipFill>
-        <p:spPr>
-          <a:xfrm>
-            <a:off x="0" y="1"/>
-            <a:ext cx="7969718" cy="6858000"/>
-          </a:xfrm>
-          <a:prstGeom prst="rect">
-            <a:avLst/>
-          </a:prstGeom>
-        </p:spPr>
-      </p:pic>
-      <p:pic>
-        <p:nvPicPr>
-          <p:cNvPr id="5" name="Picture 4">
-            <a:extLst>
-              <a:ext uri="{FF2B5EF4-FFF2-40B4-BE49-F238E27FC236}">
-                <a16:creationId xmlns:a16="http://schemas.microsoft.com/office/drawing/2014/main" id="{E8496C2E-FA9D-E6DA-51AA-788C995ECBC7}"/>
-              </a:ext>
-            </a:extLst>
-          </p:cNvPr>
-          <p:cNvPicPr>
-            <a:picLocks noChangeAspect="1"/>
-          </p:cNvPicPr>
-          <p:nvPr/>
-        </p:nvPicPr>
-        <p:blipFill rotWithShape="1">
-          <a:blip r:embed="rId3"/>
-          <a:srcRect l="2174" t="73866" r="49034"/>
-          <a:stretch/>
-        </p:blipFill>
-        <p:spPr>
-          <a:xfrm>
-            <a:off x="7969719" y="0"/>
-            <a:ext cx="3888606" cy="2535614"/>
-          </a:xfrm>
-          <a:prstGeom prst="rect">
-            <a:avLst/>
-          </a:prstGeom>
-        </p:spPr>
-      </p:pic>
-      <p:pic>
-        <p:nvPicPr>
-          <p:cNvPr id="6" name="Picture 5">
-            <a:extLst>
-              <a:ext uri="{FF2B5EF4-FFF2-40B4-BE49-F238E27FC236}">
-                <a16:creationId xmlns:a16="http://schemas.microsoft.com/office/drawing/2014/main" id="{FD6AA951-4919-CC26-41AA-5A501A813E7C}"/>
-              </a:ext>
-            </a:extLst>
-          </p:cNvPr>
-          <p:cNvPicPr>
-            <a:picLocks noChangeAspect="1"/>
-          </p:cNvPicPr>
-          <p:nvPr/>
-        </p:nvPicPr>
-        <p:blipFill rotWithShape="1">
-          <a:blip r:embed="rId3"/>
-          <a:srcRect l="51208" t="73866"/>
-          <a:stretch/>
-        </p:blipFill>
-        <p:spPr>
-          <a:xfrm>
-            <a:off x="7969718" y="2304608"/>
-            <a:ext cx="3888606" cy="2535614"/>
-          </a:xfrm>
-          <a:prstGeom prst="rect">
-            <a:avLst/>
-          </a:prstGeom>
-        </p:spPr>
-      </p:pic>
-    </p:spTree>
-    <p:extLst>
-      <p:ext uri="{BB962C8B-B14F-4D97-AF65-F5344CB8AC3E}">
-        <p14:creationId xmlns:p14="http://schemas.microsoft.com/office/powerpoint/2010/main" val="2537736449"/>
-      </p:ext>
-    </p:extLst>
-  </p:cSld>
-  <p:clrMapOvr>
-    <a:masterClrMapping/>
-  </p:clrMapOvr>
-</p:sld>
-</file>
-
-<file path=ppt/slides/slide3.xml><?xml version="1.0" encoding="utf-8"?>
-<p:sld xmlns:a="http://schemas.openxmlformats.org/drawingml/2006/main" xmlns:r="http://schemas.openxmlformats.org/officeDocument/2006/relationships" xmlns:p="http://schemas.openxmlformats.org/presentationml/2006/main">
-  <p:cSld>
-    <p:spTree>
-      <p:nvGrpSpPr>
         <p:cNvPr id="1" name="">
           <a:extLst>
             <a:ext uri="{FF2B5EF4-FFF2-40B4-BE49-F238E27FC236}">
@@ -4901,14 +4762,14 @@
             <a:pPr lvl="1"/>
             <a:r>
               <a:rPr lang="en-US" dirty="0"/>
-              <a:t>If MCAR: two traits can be unrelated</a:t>
+              <a:t>If MCAR: Pick one trait that will have missing data</a:t>
             </a:r>
           </a:p>
           <a:p>
             <a:pPr lvl="1"/>
             <a:r>
               <a:rPr lang="en-US" dirty="0"/>
-              <a:t>If MAR: two traits should have some observable relationship</a:t>
+              <a:t>If MAR: two traits should have some observable relationship, but only one of them have missing values</a:t>
             </a:r>
           </a:p>
           <a:p>
@@ -4923,14 +4784,14 @@
             </a:r>
             <a:r>
               <a:rPr lang="en-US" dirty="0"/>
-              <a:t>), then </a:t>
+              <a:t>)</a:t>
             </a:r>
           </a:p>
           <a:p>
             <a:pPr lvl="1"/>
             <a:r>
               <a:rPr lang="en-US" dirty="0"/>
-              <a:t>If MNAR: two traits should not have an observable relationship</a:t>
+              <a:t>If MNAR: one trait that is not related to observed values (of other traits)</a:t>
             </a:r>
           </a:p>
           <a:p>
@@ -4954,7 +4815,7 @@
 </p:sld>
 </file>
 
-<file path=ppt/slides/slide4.xml><?xml version="1.0" encoding="utf-8"?>
+<file path=ppt/slides/slide3.xml><?xml version="1.0" encoding="utf-8"?>
 <p:sld xmlns:a="http://schemas.openxmlformats.org/drawingml/2006/main" xmlns:r="http://schemas.openxmlformats.org/officeDocument/2006/relationships" xmlns:p="http://schemas.openxmlformats.org/presentationml/2006/main">
   <p:cSld>
     <p:spTree>
@@ -5459,7 +5320,7 @@
                         <a:buNone/>
                       </a:pPr>
                       <a:r>
-                        <a:rPr lang="en-US" sz="1400">
+                        <a:rPr lang="en-US" sz="1400" dirty="0">
                           <a:effectLst/>
                         </a:rPr>
                         <a:t>1</a:t>
@@ -10184,7 +10045,7 @@
                         <a:buNone/>
                       </a:pPr>
                       <a:r>
-                        <a:rPr lang="en-US" sz="1400">
+                        <a:rPr lang="en-US" sz="1400" dirty="0">
                           <a:effectLst/>
                         </a:rPr>
                         <a:t>Brown</a:t>
@@ -15035,10 +14896,66 @@
                         <a:buNone/>
                       </a:pPr>
                       <a:r>
+                        <a:rPr lang="en-US" sz="1400" dirty="0">
+                          <a:effectLst/>
+                        </a:rPr>
+                        <a:t>25</a:t>
+                      </a:r>
+                    </a:p>
+                  </a:txBody>
+                  <a:tcPr marL="8460" marR="8460" marT="5640" marB="5640" anchor="b">
+                    <a:lnL w="9525" cap="flat" cmpd="sng" algn="ctr">
+                      <a:solidFill>
+                        <a:srgbClr val="CCCCCC"/>
+                      </a:solidFill>
+                      <a:prstDash val="solid"/>
+                      <a:round/>
+                      <a:headEnd type="none" w="med" len="med"/>
+                      <a:tailEnd type="none" w="med" len="med"/>
+                    </a:lnL>
+                    <a:lnR w="9525" cap="flat" cmpd="sng" algn="ctr">
+                      <a:solidFill>
+                        <a:srgbClr val="CCCCCC"/>
+                      </a:solidFill>
+                      <a:prstDash val="solid"/>
+                      <a:round/>
+                      <a:headEnd type="none" w="med" len="med"/>
+                      <a:tailEnd type="none" w="med" len="med"/>
+                    </a:lnR>
+                    <a:lnT w="9525" cap="flat" cmpd="sng" algn="ctr">
+                      <a:solidFill>
+                        <a:srgbClr val="CCCCCC"/>
+                      </a:solidFill>
+                      <a:prstDash val="solid"/>
+                      <a:round/>
+                      <a:headEnd type="none" w="med" len="med"/>
+                      <a:tailEnd type="none" w="med" len="med"/>
+                    </a:lnT>
+                    <a:lnB w="9525" cap="flat" cmpd="sng" algn="ctr">
+                      <a:solidFill>
+                        <a:srgbClr val="CCCCCC"/>
+                      </a:solidFill>
+                      <a:prstDash val="solid"/>
+                      <a:round/>
+                      <a:headEnd type="none" w="med" len="med"/>
+                      <a:tailEnd type="none" w="med" len="med"/>
+                    </a:lnB>
+                    <a:noFill/>
+                  </a:tcPr>
+                </a:tc>
+                <a:tc>
+                  <a:txBody>
+                    <a:bodyPr/>
+                    <a:lstStyle/>
+                    <a:p>
+                      <a:pPr algn="l" rtl="0" fontAlgn="b">
+                        <a:buNone/>
+                      </a:pPr>
+                      <a:r>
                         <a:rPr lang="en-US" sz="1400">
                           <a:effectLst/>
                         </a:rPr>
-                        <a:t>25</a:t>
+                        <a:t>Chihuahua</a:t>
                       </a:r>
                     </a:p>
                   </a:txBody>
@@ -15094,7 +15011,7 @@
                         <a:rPr lang="en-US" sz="1400">
                           <a:effectLst/>
                         </a:rPr>
-                        <a:t>Chihuahua</a:t>
+                        <a:t>7.1</a:t>
                       </a:r>
                     </a:p>
                   </a:txBody>
@@ -15147,63 +15064,7 @@
                         <a:buNone/>
                       </a:pPr>
                       <a:r>
-                        <a:rPr lang="en-US" sz="1400">
-                          <a:effectLst/>
-                        </a:rPr>
-                        <a:t>7.1</a:t>
-                      </a:r>
-                    </a:p>
-                  </a:txBody>
-                  <a:tcPr marL="8460" marR="8460" marT="5640" marB="5640" anchor="b">
-                    <a:lnL w="9525" cap="flat" cmpd="sng" algn="ctr">
-                      <a:solidFill>
-                        <a:srgbClr val="CCCCCC"/>
-                      </a:solidFill>
-                      <a:prstDash val="solid"/>
-                      <a:round/>
-                      <a:headEnd type="none" w="med" len="med"/>
-                      <a:tailEnd type="none" w="med" len="med"/>
-                    </a:lnL>
-                    <a:lnR w="9525" cap="flat" cmpd="sng" algn="ctr">
-                      <a:solidFill>
-                        <a:srgbClr val="CCCCCC"/>
-                      </a:solidFill>
-                      <a:prstDash val="solid"/>
-                      <a:round/>
-                      <a:headEnd type="none" w="med" len="med"/>
-                      <a:tailEnd type="none" w="med" len="med"/>
-                    </a:lnR>
-                    <a:lnT w="9525" cap="flat" cmpd="sng" algn="ctr">
-                      <a:solidFill>
-                        <a:srgbClr val="CCCCCC"/>
-                      </a:solidFill>
-                      <a:prstDash val="solid"/>
-                      <a:round/>
-                      <a:headEnd type="none" w="med" len="med"/>
-                      <a:tailEnd type="none" w="med" len="med"/>
-                    </a:lnT>
-                    <a:lnB w="9525" cap="flat" cmpd="sng" algn="ctr">
-                      <a:solidFill>
-                        <a:srgbClr val="CCCCCC"/>
-                      </a:solidFill>
-                      <a:prstDash val="solid"/>
-                      <a:round/>
-                      <a:headEnd type="none" w="med" len="med"/>
-                      <a:tailEnd type="none" w="med" len="med"/>
-                    </a:lnB>
-                    <a:noFill/>
-                  </a:tcPr>
-                </a:tc>
-                <a:tc>
-                  <a:txBody>
-                    <a:bodyPr/>
-                    <a:lstStyle/>
-                    <a:p>
-                      <a:pPr algn="l" rtl="0" fontAlgn="b">
-                        <a:buNone/>
-                      </a:pPr>
-                      <a:r>
-                        <a:rPr lang="en-US" sz="1400">
+                        <a:rPr lang="en-US" sz="1400" dirty="0">
                           <a:effectLst/>
                         </a:rPr>
                         <a:t>10.6</a:t>
@@ -15430,10 +15291,10 @@
       </p:graphicFrame>
       <p:sp>
         <p:nvSpPr>
-          <p:cNvPr id="3" name="Rectangle 2">
+          <p:cNvPr id="9" name="Rectangle 8">
             <a:extLst>
               <a:ext uri="{FF2B5EF4-FFF2-40B4-BE49-F238E27FC236}">
-                <a16:creationId xmlns:a16="http://schemas.microsoft.com/office/drawing/2014/main" id="{80640622-CD0A-12E1-2990-43DA118784DC}"/>
+                <a16:creationId xmlns:a16="http://schemas.microsoft.com/office/drawing/2014/main" id="{21C2D89B-9296-E8FB-C3A6-4E9AD2D446DE}"/>
               </a:ext>
             </a:extLst>
           </p:cNvPr>
@@ -15442,16 +15303,14 @@
         </p:nvSpPr>
         <p:spPr>
           <a:xfrm>
-            <a:off x="10897685" y="5060331"/>
-            <a:ext cx="933649" cy="298905"/>
+            <a:off x="6831623" y="1275451"/>
+            <a:ext cx="1780271" cy="298905"/>
           </a:xfrm>
           <a:prstGeom prst="rect">
             <a:avLst/>
           </a:prstGeom>
           <a:solidFill>
-            <a:srgbClr val="D6285E">
-              <a:alpha val="21569"/>
-            </a:srgbClr>
+            <a:srgbClr val="C2342F"/>
           </a:solidFill>
         </p:spPr>
         <p:style>
@@ -15475,16 +15334,16 @@
           <a:lstStyle/>
           <a:p>
             <a:pPr algn="ctr"/>
-            <a:endParaRPr lang="en-US"/>
+            <a:endParaRPr lang="en-US" dirty="0"/>
           </a:p>
         </p:txBody>
       </p:sp>
       <p:sp>
         <p:nvSpPr>
-          <p:cNvPr id="4" name="Rectangle 3">
+          <p:cNvPr id="10" name="Rectangle 9">
             <a:extLst>
               <a:ext uri="{FF2B5EF4-FFF2-40B4-BE49-F238E27FC236}">
-                <a16:creationId xmlns:a16="http://schemas.microsoft.com/office/drawing/2014/main" id="{B2EFA23B-ECB3-AA31-C83D-2369F74E6BDA}"/>
+                <a16:creationId xmlns:a16="http://schemas.microsoft.com/office/drawing/2014/main" id="{B954FECB-A05C-7063-0F69-60A9352C51EF}"/>
               </a:ext>
             </a:extLst>
           </p:cNvPr>
@@ -15493,16 +15352,14 @@
         </p:nvSpPr>
         <p:spPr>
           <a:xfrm>
-            <a:off x="10808077" y="5038559"/>
-            <a:ext cx="933649" cy="298905"/>
+            <a:off x="6937132" y="6631783"/>
+            <a:ext cx="1674764" cy="298905"/>
           </a:xfrm>
           <a:prstGeom prst="rect">
             <a:avLst/>
           </a:prstGeom>
           <a:solidFill>
-            <a:srgbClr val="D6285E">
-              <a:alpha val="21569"/>
-            </a:srgbClr>
+            <a:srgbClr val="C2342F"/>
           </a:solidFill>
         </p:spPr>
         <p:style>
@@ -15526,16 +15383,16 @@
           <a:lstStyle/>
           <a:p>
             <a:pPr algn="ctr"/>
-            <a:endParaRPr lang="en-US"/>
+            <a:endParaRPr lang="en-US" dirty="0"/>
           </a:p>
         </p:txBody>
       </p:sp>
       <p:sp>
         <p:nvSpPr>
-          <p:cNvPr id="5" name="Rectangle 4">
+          <p:cNvPr id="11" name="Rectangle 10">
             <a:extLst>
               <a:ext uri="{FF2B5EF4-FFF2-40B4-BE49-F238E27FC236}">
-                <a16:creationId xmlns:a16="http://schemas.microsoft.com/office/drawing/2014/main" id="{92C4BBCC-9CFE-34D2-C59C-0DFF773474F9}"/>
+                <a16:creationId xmlns:a16="http://schemas.microsoft.com/office/drawing/2014/main" id="{8E2F7161-B525-D777-225F-D6DFF6E74DF8}"/>
               </a:ext>
             </a:extLst>
           </p:cNvPr>
@@ -15544,16 +15401,14 @@
         </p:nvSpPr>
         <p:spPr>
           <a:xfrm>
-            <a:off x="10960477" y="5190959"/>
-            <a:ext cx="933649" cy="298905"/>
+            <a:off x="6937131" y="6075788"/>
+            <a:ext cx="1797625" cy="298905"/>
           </a:xfrm>
           <a:prstGeom prst="rect">
             <a:avLst/>
           </a:prstGeom>
           <a:solidFill>
-            <a:srgbClr val="D6285E">
-              <a:alpha val="21569"/>
-            </a:srgbClr>
+            <a:srgbClr val="C2342F"/>
           </a:solidFill>
         </p:spPr>
         <p:style>
@@ -15577,16 +15432,16 @@
           <a:lstStyle/>
           <a:p>
             <a:pPr algn="ctr"/>
-            <a:endParaRPr lang="en-US"/>
+            <a:endParaRPr lang="en-US" dirty="0"/>
           </a:p>
         </p:txBody>
       </p:sp>
       <p:sp>
         <p:nvSpPr>
-          <p:cNvPr id="6" name="Rectangle 5">
+          <p:cNvPr id="12" name="Rectangle 11">
             <a:extLst>
               <a:ext uri="{FF2B5EF4-FFF2-40B4-BE49-F238E27FC236}">
-                <a16:creationId xmlns:a16="http://schemas.microsoft.com/office/drawing/2014/main" id="{37C5154C-91EF-E26E-E0CE-CE84D97B18DB}"/>
+                <a16:creationId xmlns:a16="http://schemas.microsoft.com/office/drawing/2014/main" id="{F05A0DDA-5AD8-2A70-1A1B-73CAF24C46FF}"/>
               </a:ext>
             </a:extLst>
           </p:cNvPr>
@@ -15595,16 +15450,14 @@
         </p:nvSpPr>
         <p:spPr>
           <a:xfrm>
-            <a:off x="11112877" y="5343359"/>
-            <a:ext cx="933649" cy="298905"/>
+            <a:off x="6937131" y="5592474"/>
+            <a:ext cx="1692118" cy="298905"/>
           </a:xfrm>
           <a:prstGeom prst="rect">
             <a:avLst/>
           </a:prstGeom>
           <a:solidFill>
-            <a:srgbClr val="D6285E">
-              <a:alpha val="21569"/>
-            </a:srgbClr>
+            <a:srgbClr val="C2342F"/>
           </a:solidFill>
         </p:spPr>
         <p:style>
@@ -15628,7 +15481,7 @@
           <a:lstStyle/>
           <a:p>
             <a:pPr algn="ctr"/>
-            <a:endParaRPr lang="en-US"/>
+            <a:endParaRPr lang="en-US" dirty="0"/>
           </a:p>
         </p:txBody>
       </p:sp>
@@ -15645,7 +15498,7 @@
 </p:sld>
 </file>
 
-<file path=ppt/slides/slide5.xml><?xml version="1.0" encoding="utf-8"?>
+<file path=ppt/slides/slide4.xml><?xml version="1.0" encoding="utf-8"?>
 <p:sld xmlns:a="http://schemas.openxmlformats.org/drawingml/2006/main" xmlns:r="http://schemas.openxmlformats.org/officeDocument/2006/relationships" xmlns:p="http://schemas.openxmlformats.org/presentationml/2006/main">
   <p:cSld>
     <p:spTree>
@@ -15797,7 +15650,7 @@
 </p:sld>
 </file>
 
-<file path=ppt/slides/slide6.xml><?xml version="1.0" encoding="utf-8"?>
+<file path=ppt/slides/slide5.xml><?xml version="1.0" encoding="utf-8"?>
 <p:sld xmlns:a="http://schemas.openxmlformats.org/drawingml/2006/main" xmlns:r="http://schemas.openxmlformats.org/officeDocument/2006/relationships" xmlns:p="http://schemas.openxmlformats.org/presentationml/2006/main">
   <p:cSld>
     <p:spTree>
@@ -15919,7 +15772,7 @@
 </p:sld>
 </file>
 
-<file path=ppt/slides/slide7.xml><?xml version="1.0" encoding="utf-8"?>
+<file path=ppt/slides/slide6.xml><?xml version="1.0" encoding="utf-8"?>
 <p:sld xmlns:a="http://schemas.openxmlformats.org/drawingml/2006/main" xmlns:r="http://schemas.openxmlformats.org/officeDocument/2006/relationships" xmlns:p="http://schemas.openxmlformats.org/presentationml/2006/main">
   <p:cSld>
     <p:spTree>
@@ -16002,7 +15855,7 @@
 </p:sld>
 </file>
 
-<file path=ppt/slides/slide8.xml><?xml version="1.0" encoding="utf-8"?>
+<file path=ppt/slides/slide7.xml><?xml version="1.0" encoding="utf-8"?>
 <p:sld xmlns:a="http://schemas.openxmlformats.org/drawingml/2006/main" xmlns:r="http://schemas.openxmlformats.org/officeDocument/2006/relationships" xmlns:p="http://schemas.openxmlformats.org/presentationml/2006/main">
   <p:cSld>
     <p:spTree>

</xml_diff>